<commit_message>
docs(deck): refresh for the live deployment, the native DronaHQ app and honest status
Co-Authored-By: Claude Sonnet 5 <noreply@anthropic.com>
</commit_message>
<xml_diff>
--- a/docs/deck/Cadence.pptx
+++ b/docs/deck/Cadence.pptx
@@ -18,6 +18,7 @@
     <p:sldId id="266" r:id="rId17"/>
     <p:sldId id="267" r:id="rId18"/>
     <p:sldId id="268" r:id="rId19"/>
+    <p:sldId id="269" r:id="rId20"/>
   </p:sldIdLst>
   <p:sldSz cx="12191695" cy="6858000" type="screen4x3"/>
   <p:notesSz cx="6858000" cy="9144000"/>
@@ -3269,6 +3270,21 @@
               </a:defRPr>
             </a:pPr>
             <a:r>
+              <a:t>•  Live: buildathon-2026-production.up.railway.app</a:t>
+            </a:r>
+          </a:p>
+          <a:p>
+            <a:pPr>
+              <a:spcAft>
+                <a:spcPts val="800"/>
+              </a:spcAft>
+              <a:defRPr sz="2200">
+                <a:solidFill>
+                  <a:srgbClr val="1F201D"/>
+                </a:solidFill>
+              </a:defRPr>
+            </a:pPr>
+            <a:r>
               <a:t>•  Tech Contingent x DronaHQ Inter Guild Buildathon 2026</a:t>
             </a:r>
           </a:p>
@@ -3388,7 +3404,7 @@
               </a:defRPr>
             </a:pPr>
             <a:r>
-              <a:t>Measurement</a:t>
+              <a:t>Grounded, explainable personalisation</a:t>
             </a:r>
           </a:p>
         </p:txBody>
@@ -3423,21 +3439,45 @@
               </a:defRPr>
             </a:pPr>
             <a:r>
-              <a:t>Measured from the database, never typed in</a:t>
-            </a:r>
-          </a:p>
-        </p:txBody>
-      </p:sp>
-      <p:sp>
-        <p:nvSpPr>
-          <p:cNvPr id="5" name="TextBox 4"/>
+              <a:t>Every claim traces to a source, and a decision trace shows why</a:t>
+            </a:r>
+          </a:p>
+        </p:txBody>
+      </p:sp>
+      <p:pic>
+        <p:nvPicPr>
+          <p:cNvPr id="5" name="Picture 4" descr="prospects_sam-okafor.png"/>
+          <p:cNvPicPr>
+            <a:picLocks noChangeAspect="1"/>
+          </p:cNvPicPr>
+          <p:nvPr/>
+        </p:nvPicPr>
+        <p:blipFill>
+          <a:blip r:embed="rId2"/>
+          <a:stretch>
+            <a:fillRect/>
+          </a:stretch>
+        </p:blipFill>
+        <p:spPr>
+          <a:xfrm>
+            <a:off x="548640" y="1463040"/>
+            <a:ext cx="6766560" cy="3804332"/>
+          </a:xfrm>
+          <a:prstGeom prst="rect">
+            <a:avLst/>
+          </a:prstGeom>
+        </p:spPr>
+      </p:pic>
+      <p:sp>
+        <p:nvSpPr>
+          <p:cNvPr id="6" name="TextBox 5"/>
           <p:cNvSpPr txBox="1"/>
           <p:nvPr/>
         </p:nvSpPr>
         <p:spPr>
           <a:xfrm>
-            <a:off x="548640" y="1554480"/>
-            <a:ext cx="10972800" cy="4846320"/>
+            <a:off x="7589520" y="1554480"/>
+            <a:ext cx="4206240" cy="4846320"/>
           </a:xfrm>
           <a:prstGeom prst="rect">
             <a:avLst/>
@@ -3454,14 +3494,14 @@
               <a:spcAft>
                 <a:spcPts val="800"/>
               </a:spcAft>
-              <a:defRPr sz="1700">
-                <a:solidFill>
-                  <a:srgbClr val="1F201D"/>
-                </a:solidFill>
-              </a:defRPr>
-            </a:pPr>
-            <a:r>
-              <a:t>•  C1: 30 prospects, 18 contacted, reply rate 50%, meetings 2, cost per qualified lead $0.08</a:t>
+              <a:defRPr sz="1600">
+                <a:solidFill>
+                  <a:srgbClr val="1F201D"/>
+                </a:solidFill>
+              </a:defRPr>
+            </a:pPr>
+            <a:r>
+              <a:t>•  Facts carry a source URL and a confidence.</a:t>
             </a:r>
           </a:p>
           <a:p>
@@ -3469,14 +3509,14 @@
               <a:spcAft>
                 <a:spcPts val="800"/>
               </a:spcAft>
-              <a:defRPr sz="1700">
-                <a:solidFill>
-                  <a:srgbClr val="1F201D"/>
-                </a:solidFill>
-              </a:defRPr>
-            </a:pPr>
-            <a:r>
-              <a:t>•  C2: 30 prospects, 11 contacted, reply rate 45%, meetings 1, cost per qualified lead $0.08</a:t>
+              <a:defRPr sz="1600">
+                <a:solidFill>
+                  <a:srgbClr val="1F201D"/>
+                </a:solidFill>
+              </a:defRPr>
+            </a:pPr>
+            <a:r>
+              <a:t>•  Retrieval is campaign-scoped and hybrid.</a:t>
             </a:r>
           </a:p>
           <a:p>
@@ -3484,14 +3524,14 @@
               <a:spcAft>
                 <a:spcPts val="800"/>
               </a:spcAft>
-              <a:defRPr sz="1700">
-                <a:solidFill>
-                  <a:srgbClr val="1F201D"/>
-                </a:solidFill>
-              </a:defRPr>
-            </a:pPr>
-            <a:r>
-              <a:t>•  C3: 30 prospects, 16 contacted, reply rate 50%, meetings 3, cost per qualified lead $0.10</a:t>
+              <a:defRPr sz="1600">
+                <a:solidFill>
+                  <a:srgbClr val="1F201D"/>
+                </a:solidFill>
+              </a:defRPr>
+            </a:pPr>
+            <a:r>
+              <a:t>•  Numbers must appear in their cited source. Banned phrases never pass.</a:t>
             </a:r>
           </a:p>
           <a:p>
@@ -3499,14 +3539,14 @@
               <a:spcAft>
                 <a:spcPts val="800"/>
               </a:spcAft>
-              <a:defRPr sz="1700">
-                <a:solidFill>
-                  <a:srgbClr val="1F201D"/>
-                </a:solidFill>
-              </a:defRPr>
-            </a:pPr>
-            <a:r>
-              <a:t>•  Golden sets, 15 seeded cases per agent, scored by the runner: C1 Writer v1 60% and v2 100%.</a:t>
+              <a:defRPr sz="1600">
+                <a:solidFill>
+                  <a:srgbClr val="1F201D"/>
+                </a:solidFill>
+              </a:defRPr>
+            </a:pPr>
+            <a:r>
+              <a:t>•  Two grounding failures fall back to a generic-safe draft or a human.</a:t>
             </a:r>
           </a:p>
         </p:txBody>
@@ -3610,7 +3650,7 @@
               </a:defRPr>
             </a:pPr>
             <a:r>
-              <a:t>Reliability</a:t>
+              <a:t>Measurement</a:t>
             </a:r>
           </a:p>
         </p:txBody>
@@ -3645,7 +3685,7 @@
               </a:defRPr>
             </a:pPr>
             <a:r>
-              <a:t>Built to fail cleanly</a:t>
+              <a:t>Measured from the database, never typed in</a:t>
             </a:r>
           </a:p>
         </p:txBody>
@@ -3676,14 +3716,14 @@
               <a:spcAft>
                 <a:spcPts val="800"/>
               </a:spcAft>
-              <a:defRPr sz="1800">
-                <a:solidFill>
-                  <a:srgbClr val="1F201D"/>
-                </a:solidFill>
-              </a:defRPr>
-            </a:pPr>
-            <a:r>
-              <a:t>•  86 tests against a real Postgres: every gate check, conflict cases K1 to K9, the send race, pause isolation, stop levels.</a:t>
+              <a:defRPr sz="1700">
+                <a:solidFill>
+                  <a:srgbClr val="1F201D"/>
+                </a:solidFill>
+              </a:defRPr>
+            </a:pPr>
+            <a:r>
+              <a:t>•  C1: 30 prospects, 18 contacted, reply rate 50%, meetings 2, cost per qualified lead $0.08</a:t>
             </a:r>
           </a:p>
           <a:p>
@@ -3691,14 +3731,14 @@
               <a:spcAft>
                 <a:spcPts val="800"/>
               </a:spcAft>
-              <a:defRPr sz="1800">
-                <a:solidFill>
-                  <a:srgbClr val="1F201D"/>
-                </a:solidFill>
-              </a:defRPr>
-            </a:pPr>
-            <a:r>
-              <a:t>•  LLM failure injection: invalid JSON, empty output, wrong schema, timeouts, 429s. The Qualifier never qualifies on failure.</a:t>
+              <a:defRPr sz="1700">
+                <a:solidFill>
+                  <a:srgbClr val="1F201D"/>
+                </a:solidFill>
+              </a:defRPr>
+            </a:pPr>
+            <a:r>
+              <a:t>•  C2: 30 prospects, 11 contacted, reply rate 45%, meetings 1, cost per qualified lead $0.08</a:t>
             </a:r>
           </a:p>
           <a:p>
@@ -3706,14 +3746,14 @@
               <a:spcAft>
                 <a:spcPts val="800"/>
               </a:spcAft>
-              <a:defRPr sz="1800">
-                <a:solidFill>
-                  <a:srgbClr val="1F201D"/>
-                </a:solidFill>
-              </a:defRPr>
-            </a:pPr>
-            <a:r>
-              <a:t>•  Webhook secrets, JWT roles, injection, CORS, rate limits, and a log scan for emails.</a:t>
+              <a:defRPr sz="1700">
+                <a:solidFill>
+                  <a:srgbClr val="1F201D"/>
+                </a:solidFill>
+              </a:defRPr>
+            </a:pPr>
+            <a:r>
+              <a:t>•  C3: 30 prospects, 16 contacted, reply rate 50%, meetings 3, cost per qualified lead $0.10</a:t>
             </a:r>
           </a:p>
           <a:p>
@@ -3721,14 +3761,14 @@
               <a:spcAft>
                 <a:spcPts val="800"/>
               </a:spcAft>
-              <a:defRPr sz="1800">
-                <a:solidFill>
-                  <a:srgbClr val="1F201D"/>
-                </a:solidFill>
-              </a:defRPr>
-            </a:pPr>
-            <a:r>
-              <a:t>•  One error envelope, structured logs, typed exceptions, secrets in the environment, ALLOWED_RECIPIENTS on every send.</a:t>
+              <a:defRPr sz="1700">
+                <a:solidFill>
+                  <a:srgbClr val="1F201D"/>
+                </a:solidFill>
+              </a:defRPr>
+            </a:pPr>
+            <a:r>
+              <a:t>•  Golden sets, 15 seeded cases per agent, scored by the runner: C1 Writer v1 20% and v2 20% and v3 0%.</a:t>
             </a:r>
           </a:p>
         </p:txBody>
@@ -3832,7 +3872,7 @@
               </a:defRPr>
             </a:pPr>
             <a:r>
-              <a:t>What works, and what is honest</a:t>
+              <a:t>Reliability</a:t>
             </a:r>
           </a:p>
         </p:txBody>
@@ -3867,7 +3907,7 @@
               </a:defRPr>
             </a:pPr>
             <a:r>
-              <a:t>Sandbox is an approved state and the badge tells the truth</a:t>
+              <a:t>Built to fail cleanly</a:t>
             </a:r>
           </a:p>
         </p:txBody>
@@ -3905,7 +3945,7 @@
               </a:defRPr>
             </a:pPr>
             <a:r>
-              <a:t>•  Working: campaigns, lifecycle, gate, conflicts, prompts and replay, RAG, evals, approvals, reps, analytics, MCP, voice webhooks.</a:t>
+              <a:t>•  99 tests against a real Postgres: every gate check, conflict cases K1 to K9, the send race, pause isolation, stop levels.</a:t>
             </a:r>
           </a:p>
           <a:p>
@@ -3920,7 +3960,7 @@
               </a:defRPr>
             </a:pPr>
             <a:r>
-              <a:t>•  Built, waiting for credentials: Gmail, Twilio and the DronaHQ hosted agents. Until then they run in sandbox or on the direct provider.</a:t>
+              <a:t>•  LLM failure injection: invalid JSON, empty output, wrong schema, timeouts, 429s that wait as long as the provider asks. The Qualifier never qualifies on failure.</a:t>
             </a:r>
           </a:p>
           <a:p>
@@ -3935,7 +3975,7 @@
               </a:defRPr>
             </a:pPr>
             <a:r>
-              <a:t>•  LinkedIn is a sandbox by design. Offline agents use estimated costs. Golden sets are small.</a:t>
+              <a:t>•  Webhook secrets, JWT roles, injection, CORS, rate limits, and a log scan for emails.</a:t>
             </a:r>
           </a:p>
           <a:p>
@@ -3950,7 +3990,7 @@
               </a:defRPr>
             </a:pPr>
             <a:r>
-              <a:t>•  Full list: docs/report/report.md</a:t>
+              <a:t>•  One error envelope, structured logs, typed exceptions, secrets in the environment, ALLOWED_RECIPIENTS on every send.</a:t>
             </a:r>
           </a:p>
         </p:txBody>
@@ -4054,6 +4094,228 @@
               </a:defRPr>
             </a:pPr>
             <a:r>
+              <a:t>What works, and what is honest</a:t>
+            </a:r>
+          </a:p>
+        </p:txBody>
+      </p:sp>
+      <p:sp>
+        <p:nvSpPr>
+          <p:cNvPr id="4" name="TextBox 3"/>
+          <p:cNvSpPr txBox="1"/>
+          <p:nvPr/>
+        </p:nvSpPr>
+        <p:spPr>
+          <a:xfrm>
+            <a:off x="548640" y="777240"/>
+            <a:ext cx="10972800" cy="365760"/>
+          </a:xfrm>
+          <a:prstGeom prst="rect">
+            <a:avLst/>
+          </a:prstGeom>
+          <a:noFill/>
+        </p:spPr>
+        <p:txBody>
+          <a:bodyPr wrap="none">
+            <a:spAutoFit/>
+          </a:bodyPr>
+          <a:lstStyle/>
+          <a:p>
+            <a:pPr>
+              <a:defRPr sz="1500">
+                <a:solidFill>
+                  <a:srgbClr val="5D5E58"/>
+                </a:solidFill>
+              </a:defRPr>
+            </a:pPr>
+            <a:r>
+              <a:t>Sandbox is an approved state and the badge tells the truth</a:t>
+            </a:r>
+          </a:p>
+        </p:txBody>
+      </p:sp>
+      <p:sp>
+        <p:nvSpPr>
+          <p:cNvPr id="5" name="TextBox 4"/>
+          <p:cNvSpPr txBox="1"/>
+          <p:nvPr/>
+        </p:nvSpPr>
+        <p:spPr>
+          <a:xfrm>
+            <a:off x="548640" y="1554480"/>
+            <a:ext cx="10972800" cy="4846320"/>
+          </a:xfrm>
+          <a:prstGeom prst="rect">
+            <a:avLst/>
+          </a:prstGeom>
+          <a:noFill/>
+        </p:spPr>
+        <p:txBody>
+          <a:bodyPr wrap="square">
+            <a:spAutoFit/>
+          </a:bodyPr>
+          <a:lstStyle/>
+          <a:p>
+            <a:pPr>
+              <a:spcAft>
+                <a:spcPts val="800"/>
+              </a:spcAft>
+              <a:defRPr sz="1800">
+                <a:solidFill>
+                  <a:srgbClr val="1F201D"/>
+                </a:solidFill>
+              </a:defRPr>
+            </a:pPr>
+            <a:r>
+              <a:t>•  Working live: campaigns, lifecycle, gate, conflicts, prompts and replay, RAG, evals, approvals, reps, analytics, MCP, and Gmail end to end (send, reply, classify, book).</a:t>
+            </a:r>
+          </a:p>
+          <a:p>
+            <a:pPr>
+              <a:spcAft>
+                <a:spcPts val="800"/>
+              </a:spcAft>
+              <a:defRPr sz="1800">
+                <a:solidFill>
+                  <a:srgbClr val="1F201D"/>
+                </a:solidFill>
+              </a:defRPr>
+            </a:pPr>
+            <a:r>
+              <a:t>•  Partial: SMS (Twilio connected, first real text untested), voice (sandbox), and the hosted DronaHQ agents until they are switched on. Each falls back to sandbox or the direct provider.</a:t>
+            </a:r>
+          </a:p>
+          <a:p>
+            <a:pPr>
+              <a:spcAft>
+                <a:spcPts val="800"/>
+              </a:spcAft>
+              <a:defRPr sz="1800">
+                <a:solidFill>
+                  <a:srgbClr val="1F201D"/>
+                </a:solidFill>
+              </a:defRPr>
+            </a:pPr>
+            <a:r>
+              <a:t>•  LinkedIn is a sandbox by design. Golden sets are small and the live-model scores depend on the provider's rate limit.</a:t>
+            </a:r>
+          </a:p>
+          <a:p>
+            <a:pPr>
+              <a:spcAft>
+                <a:spcPts val="800"/>
+              </a:spcAft>
+              <a:defRPr sz="1800">
+                <a:solidFill>
+                  <a:srgbClr val="1F201D"/>
+                </a:solidFill>
+              </a:defRPr>
+            </a:pPr>
+            <a:r>
+              <a:t>•  Full list: docs/report/report.md</a:t>
+            </a:r>
+          </a:p>
+        </p:txBody>
+      </p:sp>
+    </p:spTree>
+  </p:cSld>
+  <p:clrMapOvr>
+    <a:masterClrMapping/>
+  </p:clrMapOvr>
+</p:sld>
+</file>
+
+<file path=ppt/slides/slide14.xml><?xml version="1.0" encoding="utf-8"?>
+<p:sld xmlns:a="http://schemas.openxmlformats.org/drawingml/2006/main" xmlns:p="http://schemas.openxmlformats.org/presentationml/2006/main" xmlns:r="http://schemas.openxmlformats.org/officeDocument/2006/relationships">
+  <p:cSld>
+    <p:bg>
+      <p:bgPr>
+        <a:solidFill>
+          <a:srgbClr val="FFFFFF"/>
+        </a:solidFill>
+        <a:effectLst/>
+      </p:bgPr>
+    </p:bg>
+    <p:spTree>
+      <p:nvGrpSpPr>
+        <p:cNvPr id="1" name=""/>
+        <p:cNvGrpSpPr/>
+        <p:nvPr/>
+      </p:nvGrpSpPr>
+      <p:grpSpPr/>
+      <p:sp>
+        <p:nvSpPr>
+          <p:cNvPr id="2" name="Rectangle 1"/>
+          <p:cNvSpPr/>
+          <p:nvPr/>
+        </p:nvSpPr>
+        <p:spPr>
+          <a:xfrm>
+            <a:off x="0" y="0"/>
+            <a:ext cx="12191695" cy="1234440"/>
+          </a:xfrm>
+          <a:prstGeom prst="rect">
+            <a:avLst/>
+          </a:prstGeom>
+          <a:solidFill>
+            <a:srgbClr val="F6F7EE"/>
+          </a:solidFill>
+          <a:ln>
+            <a:noFill/>
+          </a:ln>
+        </p:spPr>
+        <p:style>
+          <a:lnRef idx="1">
+            <a:schemeClr val="accent1"/>
+          </a:lnRef>
+          <a:fillRef idx="3">
+            <a:schemeClr val="accent1"/>
+          </a:fillRef>
+          <a:effectRef idx="2">
+            <a:schemeClr val="accent1"/>
+          </a:effectRef>
+          <a:fontRef idx="minor">
+            <a:schemeClr val="lt1"/>
+          </a:fontRef>
+        </p:style>
+        <p:txBody>
+          <a:bodyPr rtlCol="0" anchor="ctr"/>
+          <a:lstStyle/>
+          <a:p>
+            <a:pPr algn="ctr"/>
+          </a:p>
+        </p:txBody>
+      </p:sp>
+      <p:sp>
+        <p:nvSpPr>
+          <p:cNvPr id="3" name="TextBox 2"/>
+          <p:cNvSpPr txBox="1"/>
+          <p:nvPr/>
+        </p:nvSpPr>
+        <p:spPr>
+          <a:xfrm>
+            <a:off x="548640" y="256032"/>
+            <a:ext cx="10972800" cy="640080"/>
+          </a:xfrm>
+          <a:prstGeom prst="rect">
+            <a:avLst/>
+          </a:prstGeom>
+          <a:noFill/>
+        </p:spPr>
+        <p:txBody>
+          <a:bodyPr wrap="none">
+            <a:spAutoFit/>
+          </a:bodyPr>
+          <a:lstStyle/>
+          <a:p>
+            <a:pPr>
+              <a:defRPr sz="3000" b="1">
+                <a:solidFill>
+                  <a:srgbClr val="1F201D"/>
+                </a:solidFill>
+              </a:defRPr>
+            </a:pPr>
+            <a:r>
               <a:t>Try it yourself</a:t>
             </a:r>
           </a:p>
@@ -4158,6 +4420,21 @@
             </a:pPr>
             <a:r>
               <a:t>•  3. Pause a campaign and watch Agent Activity.</a:t>
+            </a:r>
+          </a:p>
+          <a:p>
+            <a:pPr>
+              <a:spcAft>
+                <a:spcPts val="800"/>
+              </a:spcAft>
+              <a:defRPr sz="2000">
+                <a:solidFill>
+                  <a:srgbClr val="1F201D"/>
+                </a:solidFill>
+              </a:defRPr>
+            </a:pPr>
+            <a:r>
+              <a:t>•  Live: buildathon-2026-production.up.railway.app</a:t>
             </a:r>
           </a:p>
           <a:p>
@@ -5926,7 +6203,7 @@
               <a:defRPr sz="1500"/>
             </a:pPr>
             <a:r>
-              <a:t>Direct, Haiku 4.5. Hard filters and the score are code</a:t>
+              <a:t>Direct, fast model. Hard filters and the score are code</a:t>
             </a:r>
           </a:p>
         </p:txBody>
@@ -6100,7 +6377,7 @@
               <a:defRPr sz="1500"/>
             </a:pPr>
             <a:r>
-              <a:t>Direct, Sonnet 5. Code lists the legal channels first</a:t>
+              <a:t>Direct, strong model. Code lists the legal channels first</a:t>
             </a:r>
           </a:p>
         </p:txBody>
@@ -6187,7 +6464,7 @@
               <a:defRPr sz="1500"/>
             </a:pPr>
             <a:r>
-              <a:t>Direct, Sonnet 5. Grounding check rejects unsourced claims</a:t>
+              <a:t>Direct, strong model. Grounding check rejects unsourced claims</a:t>
             </a:r>
           </a:p>
         </p:txBody>
@@ -6625,7 +6902,7 @@
               </a:defRPr>
             </a:pPr>
             <a:r>
-              <a:t>•  Apps Studio hosts the manager workspace, shared with Public Access.</a:t>
+              <a:t>•  Apps Studio: a native manager app with sign in, Command Center, campaigns, dashboard and kill switch, plus the full workspace embedded.</a:t>
             </a:r>
           </a:p>
           <a:p>
@@ -6640,7 +6917,7 @@
               </a:defRPr>
             </a:pPr>
             <a:r>
-              <a:t>•  The Researcher, Responder and Caller run on the DronaHQ Agentic platform and Voice.</a:t>
+              <a:t>•  The Researcher and Responder are DronaHQ Agentic platform agents. The Caller uses DronaHQ Voice.</a:t>
             </a:r>
           </a:p>
           <a:p>
@@ -6789,7 +7066,7 @@
               </a:defRPr>
             </a:pPr>
             <a:r>
-              <a:t>The policy gate</a:t>
+              <a:t>The DronaHQ manager app</a:t>
             </a:r>
           </a:p>
         </p:txBody>
@@ -6824,20 +7101,68 @@
               </a:defRPr>
             </a:pPr>
             <a:r>
-              <a:t>Ten ordered checks, one reason code each, idempotent</a:t>
-            </a:r>
-          </a:p>
-        </p:txBody>
-      </p:sp>
-      <p:sp>
-        <p:nvSpPr>
-          <p:cNvPr id="5" name="TextBox 4"/>
+              <a:t>Native Apps Studio screens on the live API (screens from a browser test against it)</a:t>
+            </a:r>
+          </a:p>
+        </p:txBody>
+      </p:sp>
+      <p:pic>
+        <p:nvPicPr>
+          <p:cNvPr id="5" name="Picture 4" descr="dronahq_app_command_center.png"/>
+          <p:cNvPicPr>
+            <a:picLocks noChangeAspect="1"/>
+          </p:cNvPicPr>
+          <p:nvPr/>
+        </p:nvPicPr>
+        <p:blipFill>
+          <a:blip r:embed="rId2"/>
+          <a:stretch>
+            <a:fillRect/>
+          </a:stretch>
+        </p:blipFill>
+        <p:spPr>
+          <a:xfrm>
+            <a:off x="457200" y="1463040"/>
+            <a:ext cx="5577840" cy="3136004"/>
+          </a:xfrm>
+          <a:prstGeom prst="rect">
+            <a:avLst/>
+          </a:prstGeom>
+        </p:spPr>
+      </p:pic>
+      <p:pic>
+        <p:nvPicPr>
+          <p:cNvPr id="6" name="Picture 5" descr="dronahq_app_campaign_dashboard.png"/>
+          <p:cNvPicPr>
+            <a:picLocks noChangeAspect="1"/>
+          </p:cNvPicPr>
+          <p:nvPr/>
+        </p:nvPicPr>
+        <p:blipFill>
+          <a:blip r:embed="rId3"/>
+          <a:stretch>
+            <a:fillRect/>
+          </a:stretch>
+        </p:blipFill>
+        <p:spPr>
+          <a:xfrm>
+            <a:off x="6217920" y="1463040"/>
+            <a:ext cx="5577840" cy="3136004"/>
+          </a:xfrm>
+          <a:prstGeom prst="rect">
+            <a:avLst/>
+          </a:prstGeom>
+        </p:spPr>
+      </p:pic>
+      <p:sp>
+        <p:nvSpPr>
+          <p:cNvPr id="7" name="TextBox 6"/>
           <p:cNvSpPr txBox="1"/>
           <p:nvPr/>
         </p:nvSpPr>
         <p:spPr>
           <a:xfrm>
-            <a:off x="548640" y="1554480"/>
+            <a:off x="548640" y="5120640"/>
             <a:ext cx="10972800" cy="4846320"/>
           </a:xfrm>
           <a:prstGeom prst="rect">
@@ -6855,74 +7180,14 @@
               <a:spcAft>
                 <a:spcPts val="800"/>
               </a:spcAft>
-              <a:defRPr sz="1900">
-                <a:solidFill>
-                  <a:srgbClr val="1F201D"/>
-                </a:solidFill>
-              </a:defRPr>
-            </a:pPr>
-            <a:r>
-              <a:t>•  1 kill switch  2 campaign Live  3 agent on  4 channel on  5 not suppressed</a:t>
-            </a:r>
-          </a:p>
-          <a:p>
-            <a:pPr>
-              <a:spcAft>
-                <a:spcPts val="800"/>
-              </a:spcAft>
-              <a:defRPr sz="1900">
-                <a:solidFill>
-                  <a:srgbClr val="1F201D"/>
-                </a:solidFill>
-              </a:defRPr>
-            </a:pPr>
-            <a:r>
-              <a:t>•  6 claim held by this campaign  7 frequency (one touch per 48 hours, four in 14 days)</a:t>
-            </a:r>
-          </a:p>
-          <a:p>
-            <a:pPr>
-              <a:spcAft>
-                <a:spcPts val="800"/>
-              </a:spcAft>
-              <a:defRPr sz="1900">
-                <a:solidFill>
-                  <a:srgbClr val="1F201D"/>
-                </a:solidFill>
-              </a:defRPr>
-            </a:pPr>
-            <a:r>
-              <a:t>•  8 rep quota and active  9 campaign and channel daily caps  10 approval rule</a:t>
-            </a:r>
-          </a:p>
-          <a:p>
-            <a:pPr>
-              <a:spcAft>
-                <a:spcPts val="800"/>
-              </a:spcAft>
-              <a:defRPr sz="1900">
-                <a:solidFill>
-                  <a:srgbClr val="1F201D"/>
-                </a:solidFill>
-              </a:defRPr>
-            </a:pPr>
-            <a:r>
-              <a:t>•  Per-prospect advisory lock, quota locks and a unique idempotency key: a race sends exactly one message.</a:t>
-            </a:r>
-          </a:p>
-          <a:p>
-            <a:pPr>
-              <a:spcAft>
-                <a:spcPts val="800"/>
-              </a:spcAft>
-              <a:defRPr sz="1900">
-                <a:solidFill>
-                  <a:srgbClr val="1F201D"/>
-                </a:solidFill>
-              </a:defRPr>
-            </a:pPr>
-            <a:r>
-              <a:t>•  A Draft campaign refuses a real send attempt with campaign_not_live.</a:t>
+              <a:defRPr sz="1600">
+                <a:solidFill>
+                  <a:srgbClr val="1F201D"/>
+                </a:solidFill>
+              </a:defRPr>
+            </a:pPr>
+            <a:r>
+              <a:t>•  Sign in, Command Center with Stop all, campaign list with pause and resume, campaign dashboard with a switch per agent, and the full workspace embedded.</a:t>
             </a:r>
           </a:p>
         </p:txBody>
@@ -7026,7 +7291,7 @@
               </a:defRPr>
             </a:pPr>
             <a:r>
-              <a:t>Campaigns run side by side</a:t>
+              <a:t>The policy gate</a:t>
             </a:r>
           </a:p>
         </p:txBody>
@@ -7061,45 +7326,21 @@
               </a:defRPr>
             </a:pPr>
             <a:r>
-              <a:t>Pausing one writes one row and leaves the others running</a:t>
-            </a:r>
-          </a:p>
-        </p:txBody>
-      </p:sp>
-      <p:pic>
-        <p:nvPicPr>
-          <p:cNvPr id="5" name="Picture 4" descr="flow_paused.png"/>
-          <p:cNvPicPr>
-            <a:picLocks noChangeAspect="1"/>
-          </p:cNvPicPr>
-          <p:nvPr/>
-        </p:nvPicPr>
-        <p:blipFill>
-          <a:blip r:embed="rId2"/>
-          <a:stretch>
-            <a:fillRect/>
-          </a:stretch>
-        </p:blipFill>
-        <p:spPr>
-          <a:xfrm>
-            <a:off x="548640" y="1463040"/>
-            <a:ext cx="6766560" cy="3804332"/>
-          </a:xfrm>
-          <a:prstGeom prst="rect">
-            <a:avLst/>
-          </a:prstGeom>
-        </p:spPr>
-      </p:pic>
-      <p:sp>
-        <p:nvSpPr>
-          <p:cNvPr id="6" name="TextBox 5"/>
+              <a:t>Ten ordered checks, one reason code each, idempotent</a:t>
+            </a:r>
+          </a:p>
+        </p:txBody>
+      </p:sp>
+      <p:sp>
+        <p:nvSpPr>
+          <p:cNvPr id="5" name="TextBox 4"/>
           <p:cNvSpPr txBox="1"/>
           <p:nvPr/>
         </p:nvSpPr>
         <p:spPr>
           <a:xfrm>
-            <a:off x="7589520" y="1554480"/>
-            <a:ext cx="4206240" cy="4846320"/>
+            <a:off x="548640" y="1554480"/>
+            <a:ext cx="10972800" cy="4846320"/>
           </a:xfrm>
           <a:prstGeom prst="rect">
             <a:avLst/>
@@ -7116,14 +7357,14 @@
               <a:spcAft>
                 <a:spcPts val="800"/>
               </a:spcAft>
-              <a:defRPr sz="1600">
-                <a:solidFill>
-                  <a:srgbClr val="1F201D"/>
-                </a:solidFill>
-              </a:defRPr>
-            </a:pPr>
-            <a:r>
-              <a:t>•  Three Live campaigns, one Draft.</a:t>
+              <a:defRPr sz="1900">
+                <a:solidFill>
+                  <a:srgbClr val="1F201D"/>
+                </a:solidFill>
+              </a:defRPr>
+            </a:pPr>
+            <a:r>
+              <a:t>•  1 kill switch  2 campaign Live  3 agent on  4 channel on  5 not suppressed</a:t>
             </a:r>
           </a:p>
           <a:p>
@@ -7131,14 +7372,14 @@
               <a:spcAft>
                 <a:spcPts val="800"/>
               </a:spcAft>
-              <a:defRPr sz="1600">
-                <a:solidFill>
-                  <a:srgbClr val="1F201D"/>
-                </a:solidFill>
-              </a:defRPr>
-            </a:pPr>
-            <a:r>
-              <a:t>•  The worker's claim query joins each job to its own campaign.</a:t>
+              <a:defRPr sz="1900">
+                <a:solidFill>
+                  <a:srgbClr val="1F201D"/>
+                </a:solidFill>
+              </a:defRPr>
+            </a:pPr>
+            <a:r>
+              <a:t>•  6 claim held by this campaign  7 frequency (one touch per 48 hours, four in 14 days)</a:t>
             </a:r>
           </a:p>
           <a:p>
@@ -7146,14 +7387,14 @@
               <a:spcAft>
                 <a:spcPts val="800"/>
               </a:spcAft>
-              <a:defRPr sz="1600">
-                <a:solidFill>
-                  <a:srgbClr val="1F201D"/>
-                </a:solidFill>
-              </a:defRPr>
-            </a:pPr>
-            <a:r>
-              <a:t>•  test_pause_isolation: pause C2, and within five seconds C1 and C3 keep writing activity while C2 writes none.</a:t>
+              <a:defRPr sz="1900">
+                <a:solidFill>
+                  <a:srgbClr val="1F201D"/>
+                </a:solidFill>
+              </a:defRPr>
+            </a:pPr>
+            <a:r>
+              <a:t>•  8 rep quota and active  9 campaign and channel daily caps  10 approval rule</a:t>
             </a:r>
           </a:p>
           <a:p>
@@ -7161,14 +7402,29 @@
               <a:spcAft>
                 <a:spcPts val="800"/>
               </a:spcAft>
-              <a:defRPr sz="1600">
-                <a:solidFill>
-                  <a:srgbClr val="1F201D"/>
-                </a:solidFill>
-              </a:defRPr>
-            </a:pPr>
-            <a:r>
-              <a:t>•  Same guarantees for the agent and channel switches.</a:t>
+              <a:defRPr sz="1900">
+                <a:solidFill>
+                  <a:srgbClr val="1F201D"/>
+                </a:solidFill>
+              </a:defRPr>
+            </a:pPr>
+            <a:r>
+              <a:t>•  Per-prospect advisory lock, quota locks and a unique idempotency key: a race sends exactly one message.</a:t>
+            </a:r>
+          </a:p>
+          <a:p>
+            <a:pPr>
+              <a:spcAft>
+                <a:spcPts val="800"/>
+              </a:spcAft>
+              <a:defRPr sz="1900">
+                <a:solidFill>
+                  <a:srgbClr val="1F201D"/>
+                </a:solidFill>
+              </a:defRPr>
+            </a:pPr>
+            <a:r>
+              <a:t>•  A Draft campaign refuses a real send attempt with campaign_not_live.</a:t>
             </a:r>
           </a:p>
         </p:txBody>
@@ -7272,7 +7528,7 @@
               </a:defRPr>
             </a:pPr>
             <a:r>
-              <a:t>Grounded, explainable personalisation</a:t>
+              <a:t>Campaigns run side by side</a:t>
             </a:r>
           </a:p>
         </p:txBody>
@@ -7307,14 +7563,14 @@
               </a:defRPr>
             </a:pPr>
             <a:r>
-              <a:t>Every claim traces to a source, and a decision trace shows why</a:t>
+              <a:t>Pausing one writes one row and leaves the others running</a:t>
             </a:r>
           </a:p>
         </p:txBody>
       </p:sp>
       <p:pic>
         <p:nvPicPr>
-          <p:cNvPr id="5" name="Picture 4" descr="prospects_sam-okafor.png"/>
+          <p:cNvPr id="5" name="Picture 4" descr="flow_paused.png"/>
           <p:cNvPicPr>
             <a:picLocks noChangeAspect="1"/>
           </p:cNvPicPr>
@@ -7369,7 +7625,7 @@
               </a:defRPr>
             </a:pPr>
             <a:r>
-              <a:t>•  Facts carry a source URL and a confidence.</a:t>
+              <a:t>•  Three Live campaigns, one Draft.</a:t>
             </a:r>
           </a:p>
           <a:p>
@@ -7384,7 +7640,7 @@
               </a:defRPr>
             </a:pPr>
             <a:r>
-              <a:t>•  Retrieval is campaign-scoped and hybrid.</a:t>
+              <a:t>•  The worker's claim query joins each job to its own campaign.</a:t>
             </a:r>
           </a:p>
           <a:p>
@@ -7399,7 +7655,7 @@
               </a:defRPr>
             </a:pPr>
             <a:r>
-              <a:t>•  Numbers must appear in their cited source. Banned phrases never pass.</a:t>
+              <a:t>•  test_pause_isolation: pause C2, and within five seconds C1 and C3 keep writing activity while C2 writes none.</a:t>
             </a:r>
           </a:p>
           <a:p>
@@ -7414,7 +7670,7 @@
               </a:defRPr>
             </a:pPr>
             <a:r>
-              <a:t>•  Two grounding failures fall back to a generic-safe draft or a human.</a:t>
+              <a:t>•  Same guarantees for the agent and channel switches.</a:t>
             </a:r>
           </a:p>
         </p:txBody>

</xml_diff>

<commit_message>
docs: record the first live-model golden run and restore the deterministic scores on the deck
The live Writer numbers were rate-limited and are not a measure of the prompt.

Co-Authored-By: Claude Sonnet 5 <noreply@anthropic.com>
</commit_message>
<xml_diff>
--- a/docs/deck/Cadence.pptx
+++ b/docs/deck/Cadence.pptx
@@ -3723,7 +3723,7 @@
               </a:defRPr>
             </a:pPr>
             <a:r>
-              <a:t>•  C1: 30 prospects, 18 contacted, reply rate 50%, meetings 2, cost per qualified lead $0.08</a:t>
+              <a:t>•  C1: 30 prospects, 15 contacted, reply rate 53%, meetings 2, cost per qualified lead $0.08</a:t>
             </a:r>
           </a:p>
           <a:p>
@@ -3753,7 +3753,7 @@
               </a:defRPr>
             </a:pPr>
             <a:r>
-              <a:t>•  C3: 30 prospects, 16 contacted, reply rate 50%, meetings 3, cost per qualified lead $0.10</a:t>
+              <a:t>•  C3: 30 prospects, 14 contacted, reply rate 57%, meetings 2, cost per qualified lead $0.10</a:t>
             </a:r>
           </a:p>
           <a:p>
@@ -3768,7 +3768,7 @@
               </a:defRPr>
             </a:pPr>
             <a:r>
-              <a:t>•  Golden sets, 15 seeded cases per agent, scored by the runner: C1 Writer v1 20% and v2 20% and v3 0%.</a:t>
+              <a:t>•  Golden sets, 15 seeded cases per agent, scored by the runner: C1 Writer v1 60% and v2 100%.</a:t>
             </a:r>
           </a:p>
         </p:txBody>

</xml_diff>

<commit_message>
feat(linkedin): rep-assisted live mode with pasted replies
Co-Authored-By: Claude Sonnet 5 <noreply@anthropic.com>
</commit_message>
<xml_diff>
--- a/docs/deck/Cadence.pptx
+++ b/docs/deck/Cadence.pptx
@@ -4197,7 +4197,7 @@
               </a:defRPr>
             </a:pPr>
             <a:r>
-              <a:t>•  LinkedIn is a sandbox by design. Golden sets are small and the live-model scores depend on the provider's rate limit.</a:t>
+              <a:t>•  LinkedIn is rep-assisted by design: a person sends each note. Golden sets are small and the live-model scores depend on the provider's rate limit.</a:t>
             </a:r>
           </a:p>
           <a:p>
@@ -5455,7 +5455,7 @@
               </a:defRPr>
             </a:pPr>
             <a:r>
-              <a:t>Gmail, Twilio, LinkedIn sandbox, voice</a:t>
+              <a:t>Gmail, Twilio, LinkedIn (rep-assisted), voice</a:t>
             </a:r>
           </a:p>
         </p:txBody>

</xml_diff>